<commit_message>
feat: add employee devolutiva email after COPSOQ report generation
NR-01 requires that employees who participated in the assessment receive
aggregated results (preserving individual anonymity per LGPD). After report
generation, the system now sends devolutiva emails to all respondents with:
- Overall risk level, participation stats
- Critical dimensions and positive points
- Note about privacy/anonymity of individual responses
- Planned actions summary

Includes bulk sending with batching (5/batch, 500ms delay) and updated
SamurAI flowchart reflecting the new Phase 5 email flow.

Co-Authored-By: Claude Opus 4.6 <noreply@anthropic.com>
</commit_message>
<xml_diff>
--- a/docs/SamurAI_Fluxograma_NR01.pptx
+++ b/docs/SamurAI_Fluxograma_NR01.pptx
@@ -8284,7 +8284,7 @@
                 <a:ea typeface="Arial" pitchFamily="34" charset="-122"/>
                 <a:cs typeface="Arial" pitchFamily="34" charset="-120"/>
               </a:rPr>
-              <a:t>Analise por IA</a:t>
+              <a:t>Analise por IA e Devolutiva</a:t>
             </a:r>
             <a:endParaRPr lang="en-US" sz="800" dirty="0"/>
           </a:p>
@@ -8299,7 +8299,7 @@
         <p:spPr>
           <a:xfrm>
             <a:off x="7251192" y="2057400"/>
-            <a:ext cx="1554480" cy="640080"/>
+            <a:ext cx="1554480" cy="411480"/>
           </a:xfrm>
           <a:prstGeom prst="rect">
             <a:avLst/>
@@ -8323,7 +8323,7 @@
                 <a:ea typeface="Arial" pitchFamily="34" charset="-122"/>
                 <a:cs typeface="Arial" pitchFamily="34" charset="-120"/>
               </a:rPr>
-              <a:t>Relatorio COPSOQ-II com analise dimensional</a:t>
+              <a:t>Relatorio COPSOQ-II + devolutiva enviada</a:t>
             </a:r>
             <a:endParaRPr lang="en-US" sz="700" dirty="0"/>
           </a:p>
@@ -8332,6 +8332,72 @@
       <p:sp>
         <p:nvSpPr>
           <p:cNvPr id="43" name="Shape 41"/>
+          <p:cNvSpPr/>
+          <p:nvPr/>
+        </p:nvSpPr>
+        <p:spPr>
+          <a:xfrm>
+            <a:off x="7388352" y="2487168"/>
+            <a:ext cx="1280160" cy="228600"/>
+          </a:xfrm>
+          <a:prstGeom prst="roundRect">
+            <a:avLst>
+              <a:gd name="adj" fmla="val 20000"/>
+            </a:avLst>
+          </a:prstGeom>
+          <a:solidFill>
+            <a:srgbClr val="E1F5FE"/>
+          </a:solidFill>
+          <a:ln w="12700">
+            <a:solidFill>
+              <a:srgbClr val="0277BD"/>
+            </a:solidFill>
+            <a:prstDash val="solid"/>
+          </a:ln>
+        </p:spPr>
+      </p:sp>
+      <p:sp>
+        <p:nvSpPr>
+          <p:cNvPr id="44" name="Text 42"/>
+          <p:cNvSpPr/>
+          <p:nvPr/>
+        </p:nvSpPr>
+        <p:spPr>
+          <a:xfrm>
+            <a:off x="7388352" y="2487168"/>
+            <a:ext cx="1280160" cy="228600"/>
+          </a:xfrm>
+          <a:prstGeom prst="rect">
+            <a:avLst/>
+          </a:prstGeom>
+          <a:noFill/>
+          <a:ln/>
+        </p:spPr>
+        <p:txBody>
+          <a:bodyPr wrap="square" rtlCol="0" anchor="ctr"/>
+          <a:lstStyle/>
+          <a:p>
+            <a:pPr algn="ctr" indent="0" marL="0">
+              <a:buNone/>
+            </a:pPr>
+            <a:r>
+              <a:rPr lang="en-US" sz="700" b="1" dirty="0">
+                <a:solidFill>
+                  <a:srgbClr val="0277BD"/>
+                </a:solidFill>
+                <a:latin typeface="Arial" pitchFamily="34" charset="0"/>
+                <a:ea typeface="Arial" pitchFamily="34" charset="-122"/>
+                <a:cs typeface="Arial" pitchFamily="34" charset="-120"/>
+              </a:rPr>
+              <a:t>✉ 2 email(s)</a:t>
+            </a:r>
+            <a:endParaRPr lang="en-US" sz="700" dirty="0"/>
+          </a:p>
+        </p:txBody>
+      </p:sp>
+      <p:sp>
+        <p:nvSpPr>
+          <p:cNvPr id="45" name="Shape 43"/>
           <p:cNvSpPr/>
           <p:nvPr/>
         </p:nvSpPr>
@@ -8351,7 +8417,7 @@
       </p:sp>
       <p:sp>
         <p:nvSpPr>
-          <p:cNvPr id="44" name="Text 42"/>
+          <p:cNvPr id="46" name="Text 44"/>
           <p:cNvSpPr/>
           <p:nvPr/>
         </p:nvSpPr>
@@ -8390,7 +8456,7 @@
       </p:sp>
       <p:sp>
         <p:nvSpPr>
-          <p:cNvPr id="45" name="Shape 43"/>
+          <p:cNvPr id="47" name="Shape 45"/>
           <p:cNvSpPr/>
           <p:nvPr/>
         </p:nvSpPr>
@@ -8424,7 +8490,7 @@
       </p:sp>
       <p:sp>
         <p:nvSpPr>
-          <p:cNvPr id="46" name="Text 44"/>
+          <p:cNvPr id="48" name="Text 46"/>
           <p:cNvSpPr/>
           <p:nvPr/>
         </p:nvSpPr>
@@ -8463,7 +8529,7 @@
       </p:sp>
       <p:sp>
         <p:nvSpPr>
-          <p:cNvPr id="47" name="Text 45"/>
+          <p:cNvPr id="49" name="Text 47"/>
           <p:cNvSpPr/>
           <p:nvPr/>
         </p:nvSpPr>
@@ -8502,7 +8568,7 @@
       </p:sp>
       <p:sp>
         <p:nvSpPr>
-          <p:cNvPr id="48" name="Text 46"/>
+          <p:cNvPr id="50" name="Text 48"/>
           <p:cNvSpPr/>
           <p:nvPr/>
         </p:nvSpPr>
@@ -8541,7 +8607,7 @@
       </p:sp>
       <p:sp>
         <p:nvSpPr>
-          <p:cNvPr id="49" name="Text 47"/>
+          <p:cNvPr id="51" name="Text 49"/>
           <p:cNvSpPr/>
           <p:nvPr/>
         </p:nvSpPr>
@@ -8580,7 +8646,7 @@
       </p:sp>
       <p:sp>
         <p:nvSpPr>
-          <p:cNvPr id="50" name="Shape 48"/>
+          <p:cNvPr id="52" name="Shape 50"/>
           <p:cNvSpPr/>
           <p:nvPr/>
         </p:nvSpPr>
@@ -8600,7 +8666,7 @@
       </p:sp>
       <p:sp>
         <p:nvSpPr>
-          <p:cNvPr id="51" name="Text 49"/>
+          <p:cNvPr id="53" name="Text 51"/>
           <p:cNvSpPr/>
           <p:nvPr/>
         </p:nvSpPr>
@@ -8639,7 +8705,7 @@
       </p:sp>
       <p:sp>
         <p:nvSpPr>
-          <p:cNvPr id="52" name="Shape 50"/>
+          <p:cNvPr id="54" name="Shape 52"/>
           <p:cNvSpPr/>
           <p:nvPr/>
         </p:nvSpPr>
@@ -8673,7 +8739,7 @@
       </p:sp>
       <p:sp>
         <p:nvSpPr>
-          <p:cNvPr id="53" name="Text 51"/>
+          <p:cNvPr id="55" name="Text 53"/>
           <p:cNvSpPr/>
           <p:nvPr/>
         </p:nvSpPr>
@@ -8712,7 +8778,7 @@
       </p:sp>
       <p:sp>
         <p:nvSpPr>
-          <p:cNvPr id="54" name="Text 52"/>
+          <p:cNvPr id="56" name="Text 54"/>
           <p:cNvSpPr/>
           <p:nvPr/>
         </p:nvSpPr>
@@ -8751,7 +8817,7 @@
       </p:sp>
       <p:sp>
         <p:nvSpPr>
-          <p:cNvPr id="55" name="Text 53"/>
+          <p:cNvPr id="57" name="Text 55"/>
           <p:cNvSpPr/>
           <p:nvPr/>
         </p:nvSpPr>
@@ -8790,7 +8856,7 @@
       </p:sp>
       <p:sp>
         <p:nvSpPr>
-          <p:cNvPr id="56" name="Text 54"/>
+          <p:cNvPr id="58" name="Text 56"/>
           <p:cNvSpPr/>
           <p:nvPr/>
         </p:nvSpPr>
@@ -8829,7 +8895,7 @@
       </p:sp>
       <p:sp>
         <p:nvSpPr>
-          <p:cNvPr id="57" name="Shape 55"/>
+          <p:cNvPr id="59" name="Shape 57"/>
           <p:cNvSpPr/>
           <p:nvPr/>
         </p:nvSpPr>
@@ -8849,7 +8915,7 @@
       </p:sp>
       <p:sp>
         <p:nvSpPr>
-          <p:cNvPr id="58" name="Text 56"/>
+          <p:cNvPr id="60" name="Text 58"/>
           <p:cNvSpPr/>
           <p:nvPr/>
         </p:nvSpPr>
@@ -8888,7 +8954,7 @@
       </p:sp>
       <p:sp>
         <p:nvSpPr>
-          <p:cNvPr id="59" name="Shape 57"/>
+          <p:cNvPr id="61" name="Shape 59"/>
           <p:cNvSpPr/>
           <p:nvPr/>
         </p:nvSpPr>
@@ -8922,7 +8988,7 @@
       </p:sp>
       <p:sp>
         <p:nvSpPr>
-          <p:cNvPr id="60" name="Text 58"/>
+          <p:cNvPr id="62" name="Text 60"/>
           <p:cNvSpPr/>
           <p:nvPr/>
         </p:nvSpPr>
@@ -8961,7 +9027,7 @@
       </p:sp>
       <p:sp>
         <p:nvSpPr>
-          <p:cNvPr id="61" name="Text 59"/>
+          <p:cNvPr id="63" name="Text 61"/>
           <p:cNvSpPr/>
           <p:nvPr/>
         </p:nvSpPr>
@@ -9000,7 +9066,7 @@
       </p:sp>
       <p:sp>
         <p:nvSpPr>
-          <p:cNvPr id="62" name="Text 60"/>
+          <p:cNvPr id="64" name="Text 62"/>
           <p:cNvSpPr/>
           <p:nvPr/>
         </p:nvSpPr>
@@ -9039,7 +9105,7 @@
       </p:sp>
       <p:sp>
         <p:nvSpPr>
-          <p:cNvPr id="63" name="Text 61"/>
+          <p:cNvPr id="65" name="Text 63"/>
           <p:cNvSpPr/>
           <p:nvPr/>
         </p:nvSpPr>
@@ -9078,7 +9144,7 @@
       </p:sp>
       <p:sp>
         <p:nvSpPr>
-          <p:cNvPr id="64" name="Shape 62"/>
+          <p:cNvPr id="66" name="Shape 64"/>
           <p:cNvSpPr/>
           <p:nvPr/>
         </p:nvSpPr>
@@ -9098,7 +9164,7 @@
       </p:sp>
       <p:sp>
         <p:nvSpPr>
-          <p:cNvPr id="65" name="Text 63"/>
+          <p:cNvPr id="67" name="Text 65"/>
           <p:cNvSpPr/>
           <p:nvPr/>
         </p:nvSpPr>
@@ -9137,7 +9203,7 @@
       </p:sp>
       <p:sp>
         <p:nvSpPr>
-          <p:cNvPr id="66" name="Shape 64"/>
+          <p:cNvPr id="68" name="Shape 66"/>
           <p:cNvSpPr/>
           <p:nvPr/>
         </p:nvSpPr>
@@ -9171,7 +9237,7 @@
       </p:sp>
       <p:sp>
         <p:nvSpPr>
-          <p:cNvPr id="67" name="Text 65"/>
+          <p:cNvPr id="69" name="Text 67"/>
           <p:cNvSpPr/>
           <p:nvPr/>
         </p:nvSpPr>
@@ -9210,7 +9276,7 @@
       </p:sp>
       <p:sp>
         <p:nvSpPr>
-          <p:cNvPr id="68" name="Text 66"/>
+          <p:cNvPr id="70" name="Text 68"/>
           <p:cNvSpPr/>
           <p:nvPr/>
         </p:nvSpPr>
@@ -9249,7 +9315,7 @@
       </p:sp>
       <p:sp>
         <p:nvSpPr>
-          <p:cNvPr id="69" name="Text 67"/>
+          <p:cNvPr id="71" name="Text 69"/>
           <p:cNvSpPr/>
           <p:nvPr/>
         </p:nvSpPr>
@@ -9288,7 +9354,7 @@
       </p:sp>
       <p:sp>
         <p:nvSpPr>
-          <p:cNvPr id="70" name="Shape 68"/>
+          <p:cNvPr id="72" name="Shape 70"/>
           <p:cNvSpPr/>
           <p:nvPr/>
         </p:nvSpPr>
@@ -9315,7 +9381,7 @@
       </p:sp>
       <p:sp>
         <p:nvSpPr>
-          <p:cNvPr id="71" name="Text 69"/>
+          <p:cNvPr id="73" name="Text 71"/>
           <p:cNvSpPr/>
           <p:nvPr/>
         </p:nvSpPr>
@@ -9354,7 +9420,7 @@
       </p:sp>
       <p:sp>
         <p:nvSpPr>
-          <p:cNvPr id="72" name="Text 70"/>
+          <p:cNvPr id="74" name="Text 72"/>
           <p:cNvSpPr/>
           <p:nvPr/>
         </p:nvSpPr>
@@ -9393,7 +9459,7 @@
       </p:sp>
       <p:sp>
         <p:nvSpPr>
-          <p:cNvPr id="73" name="Shape 71"/>
+          <p:cNvPr id="75" name="Shape 73"/>
           <p:cNvSpPr/>
           <p:nvPr/>
         </p:nvSpPr>
@@ -9413,7 +9479,7 @@
       </p:sp>
       <p:sp>
         <p:nvSpPr>
-          <p:cNvPr id="74" name="Text 72"/>
+          <p:cNvPr id="76" name="Text 74"/>
           <p:cNvSpPr/>
           <p:nvPr/>
         </p:nvSpPr>
@@ -9452,7 +9518,7 @@
       </p:sp>
       <p:sp>
         <p:nvSpPr>
-          <p:cNvPr id="75" name="Shape 73"/>
+          <p:cNvPr id="77" name="Shape 75"/>
           <p:cNvSpPr/>
           <p:nvPr/>
         </p:nvSpPr>
@@ -9486,7 +9552,7 @@
       </p:sp>
       <p:sp>
         <p:nvSpPr>
-          <p:cNvPr id="76" name="Text 74"/>
+          <p:cNvPr id="78" name="Text 76"/>
           <p:cNvSpPr/>
           <p:nvPr/>
         </p:nvSpPr>
@@ -9525,7 +9591,7 @@
       </p:sp>
       <p:sp>
         <p:nvSpPr>
-          <p:cNvPr id="77" name="Text 75"/>
+          <p:cNvPr id="79" name="Text 77"/>
           <p:cNvSpPr/>
           <p:nvPr/>
         </p:nvSpPr>
@@ -9564,7 +9630,7 @@
       </p:sp>
       <p:sp>
         <p:nvSpPr>
-          <p:cNvPr id="78" name="Text 76"/>
+          <p:cNvPr id="80" name="Text 78"/>
           <p:cNvSpPr/>
           <p:nvPr/>
         </p:nvSpPr>
@@ -9603,7 +9669,7 @@
       </p:sp>
       <p:sp>
         <p:nvSpPr>
-          <p:cNvPr id="79" name="Shape 77"/>
+          <p:cNvPr id="81" name="Shape 79"/>
           <p:cNvSpPr/>
           <p:nvPr/>
         </p:nvSpPr>
@@ -9630,7 +9696,7 @@
       </p:sp>
       <p:sp>
         <p:nvSpPr>
-          <p:cNvPr id="80" name="Text 78"/>
+          <p:cNvPr id="82" name="Text 80"/>
           <p:cNvSpPr/>
           <p:nvPr/>
         </p:nvSpPr>
@@ -9669,7 +9735,7 @@
       </p:sp>
       <p:sp>
         <p:nvSpPr>
-          <p:cNvPr id="81" name="Text 79"/>
+          <p:cNvPr id="83" name="Text 81"/>
           <p:cNvSpPr/>
           <p:nvPr/>
         </p:nvSpPr>
@@ -15376,7 +15442,7 @@
                 <a:ea typeface="Arial" pitchFamily="34" charset="-122"/>
                 <a:cs typeface="Arial" pitchFamily="34" charset="-120"/>
               </a:rPr>
-              <a:t>Analise por IA</a:t>
+              <a:t>Analise por IA e Devolutiva</a:t>
             </a:r>
             <a:endParaRPr lang="en-US" sz="1400" dirty="0"/>
           </a:p>
@@ -15556,7 +15622,7 @@
         </p:nvSpPr>
         <p:spPr>
           <a:xfrm>
-            <a:off x="2834640" y="1682496"/>
+            <a:off x="2834640" y="1591056"/>
             <a:ext cx="0" cy="73152"/>
           </a:xfrm>
           <a:prstGeom prst="line">
@@ -15579,7 +15645,7 @@
         </p:nvSpPr>
         <p:spPr>
           <a:xfrm>
-            <a:off x="365760" y="1755648"/>
+            <a:off x="365760" y="1664208"/>
             <a:ext cx="4937760" cy="411480"/>
           </a:xfrm>
           <a:prstGeom prst="roundRect">
@@ -15606,7 +15672,7 @@
         </p:nvSpPr>
         <p:spPr>
           <a:xfrm>
-            <a:off x="420624" y="1810512"/>
+            <a:off x="420624" y="1719072"/>
             <a:ext cx="301752" cy="301752"/>
           </a:xfrm>
           <a:prstGeom prst="ellipse">
@@ -15626,7 +15692,7 @@
         </p:nvSpPr>
         <p:spPr>
           <a:xfrm>
-            <a:off x="420624" y="1810512"/>
+            <a:off x="420624" y="1719072"/>
             <a:ext cx="301752" cy="301752"/>
           </a:xfrm>
           <a:prstGeom prst="rect">
@@ -15665,7 +15731,7 @@
         </p:nvSpPr>
         <p:spPr>
           <a:xfrm>
-            <a:off x="822960" y="1755648"/>
+            <a:off x="822960" y="1664208"/>
             <a:ext cx="4343400" cy="411480"/>
           </a:xfrm>
           <a:prstGeom prst="rect">
@@ -15704,7 +15770,7 @@
         </p:nvSpPr>
         <p:spPr>
           <a:xfrm>
-            <a:off x="2834640" y="2340864"/>
+            <a:off x="2834640" y="2157984"/>
             <a:ext cx="0" cy="73152"/>
           </a:xfrm>
           <a:prstGeom prst="line">
@@ -15727,7 +15793,7 @@
         </p:nvSpPr>
         <p:spPr>
           <a:xfrm>
-            <a:off x="365760" y="2414016"/>
+            <a:off x="365760" y="2231136"/>
             <a:ext cx="4937760" cy="411480"/>
           </a:xfrm>
           <a:prstGeom prst="roundRect">
@@ -15754,7 +15820,7 @@
         </p:nvSpPr>
         <p:spPr>
           <a:xfrm>
-            <a:off x="420624" y="2468880"/>
+            <a:off x="420624" y="2286000"/>
             <a:ext cx="301752" cy="301752"/>
           </a:xfrm>
           <a:prstGeom prst="ellipse">
@@ -15774,7 +15840,7 @@
         </p:nvSpPr>
         <p:spPr>
           <a:xfrm>
-            <a:off x="420624" y="2468880"/>
+            <a:off x="420624" y="2286000"/>
             <a:ext cx="301752" cy="301752"/>
           </a:xfrm>
           <a:prstGeom prst="rect">
@@ -15813,7 +15879,7 @@
         </p:nvSpPr>
         <p:spPr>
           <a:xfrm>
-            <a:off x="822960" y="2414016"/>
+            <a:off x="822960" y="2231136"/>
             <a:ext cx="4343400" cy="411480"/>
           </a:xfrm>
           <a:prstGeom prst="rect">
@@ -15838,7 +15904,7 @@
                 <a:ea typeface="Arial" pitchFamily="34" charset="-122"/>
                 <a:cs typeface="Arial" pitchFamily="34" charset="-120"/>
               </a:rPr>
-              <a:t>Identifica dimensoes criticas (score &lt; 30)</a:t>
+              <a:t>Identifica dimensoes criticas (score &gt;= 70)</a:t>
             </a:r>
             <a:endParaRPr lang="en-US" sz="1000" dirty="0"/>
           </a:p>
@@ -15852,7 +15918,7 @@
         </p:nvSpPr>
         <p:spPr>
           <a:xfrm>
-            <a:off x="2834640" y="2999232"/>
+            <a:off x="2834640" y="2724912"/>
             <a:ext cx="0" cy="73152"/>
           </a:xfrm>
           <a:prstGeom prst="line">
@@ -15875,7 +15941,7 @@
         </p:nvSpPr>
         <p:spPr>
           <a:xfrm>
-            <a:off x="365760" y="3072384"/>
+            <a:off x="365760" y="2798064"/>
             <a:ext cx="4937760" cy="411480"/>
           </a:xfrm>
           <a:prstGeom prst="roundRect">
@@ -15902,7 +15968,7 @@
         </p:nvSpPr>
         <p:spPr>
           <a:xfrm>
-            <a:off x="420624" y="3127248"/>
+            <a:off x="420624" y="2852928"/>
             <a:ext cx="301752" cy="301752"/>
           </a:xfrm>
           <a:prstGeom prst="ellipse">
@@ -15922,7 +15988,7 @@
         </p:nvSpPr>
         <p:spPr>
           <a:xfrm>
-            <a:off x="420624" y="3127248"/>
+            <a:off x="420624" y="2852928"/>
             <a:ext cx="301752" cy="301752"/>
           </a:xfrm>
           <a:prstGeom prst="rect">
@@ -15961,7 +16027,7 @@
         </p:nvSpPr>
         <p:spPr>
           <a:xfrm>
-            <a:off x="822960" y="3072384"/>
+            <a:off x="822960" y="2798064"/>
             <a:ext cx="4343400" cy="411480"/>
           </a:xfrm>
           <a:prstGeom prst="rect">
@@ -16000,7 +16066,7 @@
         </p:nvSpPr>
         <p:spPr>
           <a:xfrm>
-            <a:off x="2834640" y="3657600"/>
+            <a:off x="2834640" y="3291840"/>
             <a:ext cx="0" cy="73152"/>
           </a:xfrm>
           <a:prstGeom prst="line">
@@ -16023,7 +16089,7 @@
         </p:nvSpPr>
         <p:spPr>
           <a:xfrm>
-            <a:off x="365760" y="3730752"/>
+            <a:off x="365760" y="3364992"/>
             <a:ext cx="4937760" cy="411480"/>
           </a:xfrm>
           <a:prstGeom prst="roundRect">
@@ -16050,7 +16116,7 @@
         </p:nvSpPr>
         <p:spPr>
           <a:xfrm>
-            <a:off x="420624" y="3785616"/>
+            <a:off x="420624" y="3419856"/>
             <a:ext cx="301752" cy="301752"/>
           </a:xfrm>
           <a:prstGeom prst="ellipse">
@@ -16070,7 +16136,7 @@
         </p:nvSpPr>
         <p:spPr>
           <a:xfrm>
-            <a:off x="420624" y="3785616"/>
+            <a:off x="420624" y="3419856"/>
             <a:ext cx="301752" cy="301752"/>
           </a:xfrm>
           <a:prstGeom prst="rect">
@@ -16109,7 +16175,7 @@
         </p:nvSpPr>
         <p:spPr>
           <a:xfrm>
-            <a:off x="822960" y="3730752"/>
+            <a:off x="822960" y="3364992"/>
             <a:ext cx="4343400" cy="411480"/>
           </a:xfrm>
           <a:prstGeom prst="rect">
@@ -16134,7 +16200,7 @@
                 <a:ea typeface="Arial" pitchFamily="34" charset="-122"/>
                 <a:cs typeface="Arial" pitchFamily="34" charset="-120"/>
               </a:rPr>
-              <a:t>Fallback: analise baseada em regras se IA indisponivel</a:t>
+              <a:t>Envia devolutiva agregada p/ empresa e colaboradores</a:t>
             </a:r>
             <a:endParaRPr lang="en-US" sz="1000" dirty="0"/>
           </a:p>
@@ -16239,7 +16305,7 @@
                 <a:ea typeface="Arial" pitchFamily="34" charset="-122"/>
                 <a:cs typeface="Arial" pitchFamily="34" charset="-120"/>
               </a:rPr>
-              <a:t>Relatorio COPSOQ-II com analise dimensional</a:t>
+              <a:t>Relatorio COPSOQ-II + devolutiva enviada</a:t>
             </a:r>
             <a:endParaRPr lang="en-US" sz="1100" dirty="0"/>
           </a:p>
@@ -16352,13 +16418,279 @@
       </p:sp>
       <p:sp>
         <p:nvSpPr>
-          <p:cNvPr id="36" name="Text 34"/>
-          <p:cNvSpPr/>
-          <p:nvPr/>
-        </p:nvSpPr>
-        <p:spPr>
-          <a:xfrm>
-            <a:off x="5669280" y="4114800"/>
+          <p:cNvPr id="36" name="Shape 34"/>
+          <p:cNvSpPr/>
+          <p:nvPr/>
+        </p:nvSpPr>
+        <p:spPr>
+          <a:xfrm>
+            <a:off x="5669280" y="3337560"/>
+            <a:ext cx="3200400" cy="969264"/>
+          </a:xfrm>
+          <a:prstGeom prst="roundRect">
+            <a:avLst>
+              <a:gd name="adj" fmla="val 9434"/>
+            </a:avLst>
+          </a:prstGeom>
+          <a:solidFill>
+            <a:srgbClr val="E1F5FE"/>
+          </a:solidFill>
+          <a:ln w="19050">
+            <a:solidFill>
+              <a:srgbClr val="0277BD"/>
+            </a:solidFill>
+            <a:prstDash val="solid"/>
+          </a:ln>
+        </p:spPr>
+      </p:sp>
+      <p:sp>
+        <p:nvSpPr>
+          <p:cNvPr id="37" name="Text 35"/>
+          <p:cNvSpPr/>
+          <p:nvPr/>
+        </p:nvSpPr>
+        <p:spPr>
+          <a:xfrm>
+            <a:off x="5760720" y="3355848"/>
+            <a:ext cx="3017520" cy="228600"/>
+          </a:xfrm>
+          <a:prstGeom prst="rect">
+            <a:avLst/>
+          </a:prstGeom>
+          <a:noFill/>
+          <a:ln/>
+        </p:spPr>
+        <p:txBody>
+          <a:bodyPr wrap="square" rtlCol="0" anchor="ctr"/>
+          <a:lstStyle/>
+          <a:p>
+            <a:pPr indent="0" marL="0">
+              <a:buNone/>
+            </a:pPr>
+            <a:r>
+              <a:rPr lang="en-US" sz="900" b="1" dirty="0">
+                <a:solidFill>
+                  <a:srgbClr val="0277BD"/>
+                </a:solidFill>
+                <a:latin typeface="Arial" pitchFamily="34" charset="0"/>
+                <a:ea typeface="Arial" pitchFamily="34" charset="-122"/>
+                <a:cs typeface="Arial" pitchFamily="34" charset="-120"/>
+              </a:rPr>
+              <a:t>✉  COMUNICACOES POR EMAIL</a:t>
+            </a:r>
+            <a:endParaRPr lang="en-US" sz="900" dirty="0"/>
+          </a:p>
+        </p:txBody>
+      </p:sp>
+      <p:sp>
+        <p:nvSpPr>
+          <p:cNvPr id="38" name="Shape 36"/>
+          <p:cNvSpPr/>
+          <p:nvPr/>
+        </p:nvSpPr>
+        <p:spPr>
+          <a:xfrm>
+            <a:off x="5760720" y="3611880"/>
+            <a:ext cx="1463040" cy="164592"/>
+          </a:xfrm>
+          <a:prstGeom prst="roundRect">
+            <a:avLst>
+              <a:gd name="adj" fmla="val 22222"/>
+            </a:avLst>
+          </a:prstGeom>
+          <a:solidFill>
+            <a:srgbClr val="0277BD"/>
+          </a:solidFill>
+          <a:ln/>
+        </p:spPr>
+      </p:sp>
+      <p:sp>
+        <p:nvSpPr>
+          <p:cNvPr id="39" name="Text 37"/>
+          <p:cNvSpPr/>
+          <p:nvPr/>
+        </p:nvSpPr>
+        <p:spPr>
+          <a:xfrm>
+            <a:off x="5760720" y="3611880"/>
+            <a:ext cx="1463040" cy="164592"/>
+          </a:xfrm>
+          <a:prstGeom prst="rect">
+            <a:avLst/>
+          </a:prstGeom>
+          <a:noFill/>
+          <a:ln/>
+        </p:spPr>
+        <p:txBody>
+          <a:bodyPr wrap="square" rtlCol="0" anchor="ctr"/>
+          <a:lstStyle/>
+          <a:p>
+            <a:pPr algn="ctr" indent="0" marL="0">
+              <a:buNone/>
+            </a:pPr>
+            <a:r>
+              <a:rPr lang="en-US" sz="700" b="1" dirty="0">
+                <a:solidFill>
+                  <a:srgbClr val="FFFFFF"/>
+                </a:solidFill>
+                <a:latin typeface="Arial" pitchFamily="34" charset="0"/>
+                <a:ea typeface="Arial" pitchFamily="34" charset="-122"/>
+                <a:cs typeface="Arial" pitchFamily="34" charset="-120"/>
+              </a:rPr>
+              <a:t>Sistema  →  Empresa</a:t>
+            </a:r>
+            <a:endParaRPr lang="en-US" sz="700" dirty="0"/>
+          </a:p>
+        </p:txBody>
+      </p:sp>
+      <p:sp>
+        <p:nvSpPr>
+          <p:cNvPr id="40" name="Text 38"/>
+          <p:cNvSpPr/>
+          <p:nvPr/>
+        </p:nvSpPr>
+        <p:spPr>
+          <a:xfrm>
+            <a:off x="5760720" y="3776472"/>
+            <a:ext cx="3017520" cy="164592"/>
+          </a:xfrm>
+          <a:prstGeom prst="rect">
+            <a:avLst/>
+          </a:prstGeom>
+          <a:noFill/>
+          <a:ln/>
+        </p:spPr>
+        <p:txBody>
+          <a:bodyPr wrap="square" rtlCol="0" anchor="ctr"/>
+          <a:lstStyle/>
+          <a:p>
+            <a:pPr indent="0" marL="0">
+              <a:buNone/>
+            </a:pPr>
+            <a:r>
+              <a:rPr lang="en-US" sz="800" dirty="0">
+                <a:solidFill>
+                  <a:srgbClr val="333333"/>
+                </a:solidFill>
+                <a:latin typeface="Arial" pitchFamily="34" charset="0"/>
+                <a:ea typeface="Arial" pitchFamily="34" charset="-122"/>
+                <a:cs typeface="Arial" pitchFamily="34" charset="-120"/>
+              </a:rPr>
+              <a:t>Devolutiva com resultados agregados, dimensoes criticas e pontos fortes</a:t>
+            </a:r>
+            <a:endParaRPr lang="en-US" sz="800" dirty="0"/>
+          </a:p>
+        </p:txBody>
+      </p:sp>
+      <p:sp>
+        <p:nvSpPr>
+          <p:cNvPr id="41" name="Shape 39"/>
+          <p:cNvSpPr/>
+          <p:nvPr/>
+        </p:nvSpPr>
+        <p:spPr>
+          <a:xfrm>
+            <a:off x="5760720" y="3959352"/>
+            <a:ext cx="1463040" cy="164592"/>
+          </a:xfrm>
+          <a:prstGeom prst="roundRect">
+            <a:avLst>
+              <a:gd name="adj" fmla="val 22222"/>
+            </a:avLst>
+          </a:prstGeom>
+          <a:solidFill>
+            <a:srgbClr val="0277BD"/>
+          </a:solidFill>
+          <a:ln/>
+        </p:spPr>
+      </p:sp>
+      <p:sp>
+        <p:nvSpPr>
+          <p:cNvPr id="42" name="Text 40"/>
+          <p:cNvSpPr/>
+          <p:nvPr/>
+        </p:nvSpPr>
+        <p:spPr>
+          <a:xfrm>
+            <a:off x="5760720" y="3959352"/>
+            <a:ext cx="1463040" cy="164592"/>
+          </a:xfrm>
+          <a:prstGeom prst="rect">
+            <a:avLst/>
+          </a:prstGeom>
+          <a:noFill/>
+          <a:ln/>
+        </p:spPr>
+        <p:txBody>
+          <a:bodyPr wrap="square" rtlCol="0" anchor="ctr"/>
+          <a:lstStyle/>
+          <a:p>
+            <a:pPr algn="ctr" indent="0" marL="0">
+              <a:buNone/>
+            </a:pPr>
+            <a:r>
+              <a:rPr lang="en-US" sz="700" b="1" dirty="0">
+                <a:solidFill>
+                  <a:srgbClr val="FFFFFF"/>
+                </a:solidFill>
+                <a:latin typeface="Arial" pitchFamily="34" charset="0"/>
+                <a:ea typeface="Arial" pitchFamily="34" charset="-122"/>
+                <a:cs typeface="Arial" pitchFamily="34" charset="-120"/>
+              </a:rPr>
+              <a:t>Sistema  →  Colaboradores</a:t>
+            </a:r>
+            <a:endParaRPr lang="en-US" sz="700" dirty="0"/>
+          </a:p>
+        </p:txBody>
+      </p:sp>
+      <p:sp>
+        <p:nvSpPr>
+          <p:cNvPr id="43" name="Text 41"/>
+          <p:cNvSpPr/>
+          <p:nvPr/>
+        </p:nvSpPr>
+        <p:spPr>
+          <a:xfrm>
+            <a:off x="5760720" y="4123944"/>
+            <a:ext cx="3017520" cy="164592"/>
+          </a:xfrm>
+          <a:prstGeom prst="rect">
+            <a:avLst/>
+          </a:prstGeom>
+          <a:noFill/>
+          <a:ln/>
+        </p:spPr>
+        <p:txBody>
+          <a:bodyPr wrap="square" rtlCol="0" anchor="ctr"/>
+          <a:lstStyle/>
+          <a:p>
+            <a:pPr indent="0" marL="0">
+              <a:buNone/>
+            </a:pPr>
+            <a:r>
+              <a:rPr lang="en-US" sz="800" dirty="0">
+                <a:solidFill>
+                  <a:srgbClr val="333333"/>
+                </a:solidFill>
+                <a:latin typeface="Arial" pitchFamily="34" charset="0"/>
+                <a:ea typeface="Arial" pitchFamily="34" charset="-122"/>
+                <a:cs typeface="Arial" pitchFamily="34" charset="-120"/>
+              </a:rPr>
+              <a:t>Devolutiva coletiva (anonima) com panorama geral e acoes planejadas (NR-01/LGPD)</a:t>
+            </a:r>
+            <a:endParaRPr lang="en-US" sz="800" dirty="0"/>
+          </a:p>
+        </p:txBody>
+      </p:sp>
+      <p:sp>
+        <p:nvSpPr>
+          <p:cNvPr id="44" name="Text 42"/>
+          <p:cNvSpPr/>
+          <p:nvPr/>
+        </p:nvSpPr>
+        <p:spPr>
+          <a:xfrm>
+            <a:off x="5669280" y="4663440"/>
             <a:ext cx="3200400" cy="274320"/>
           </a:xfrm>
           <a:prstGeom prst="rect">

</xml_diff>